<commit_message>
Add presenter-view speaker notes to every slide
Sixteen slides, sixteen sets of notes - cues short enough to read while talking,
not a full script. Timings, what to point at, where to pause, which slides to cut
if short on time, and the two places where raising a weakness yourself is stronger
than being caught by it (the leave-one-out ordering on slide 8, and the fact that
the degeneracy is a symptom rather than only a bug on slide 12).

Kept in deck/add_notes.py rather than added by hand, because `node deck/main12.js`
regenerates the deck from scratch and would wipe them. Build sequence is now:

    node deck/main12.js && python deck/add_notes.py

The full narration lives in PRESENTATION_GUIDE.md.

Co-Authored-By: Claude Opus 5 <noreply@anthropic.com>
</commit_message>
<xml_diff>
--- a/BTP_presentation.pptx
+++ b/BTP_presentation.pptx
@@ -516,10 +516,8 @@
           <a:lstStyle/>
           <a:p>
             <a:r>
-              <a:rPr lang="en-US" dirty="0"/>
-              <a:t>We reproduce a 2024 IEEE method on open data. The headline is not the accuracy - it is four ways this kind of pipeline produces confident wrong answers.</a:t>
-            </a:r>
-            <a:endParaRPr lang="en-US" dirty="0"/>
+              <a:t>30s. Do NOT give the conclusion yet - slides 2-5 set up the problem.</a:t>
+            </a:r>
           </a:p>
         </p:txBody>
       </p:sp>
@@ -604,10 +602,8 @@
           <a:lstStyle/>
           <a:p>
             <a:r>
-              <a:rPr lang="en-US" dirty="0"/>
-              <a:t/>
-            </a:r>
-            <a:endParaRPr lang="en-US" dirty="0"/>
+              <a:t>75s. Point at the LAST row. The baseline predicts a constant, explains zero variance, and has BOTH the best R-squared (-0.074) and the best clinical score (90.0%). Why: most readings sit in a narrow band, so a constant already lands in A and B. The grid catches DANGEROUS errors, not USELESS ones. Rule: never report a zone score without a baseline beside it.</a:t>
+            </a:r>
           </a:p>
         </p:txBody>
       </p:sp>
@@ -692,10 +688,8 @@
           <a:lstStyle/>
           <a:p>
             <a:r>
-              <a:rPr lang="en-US" dirty="0"/>
-              <a:t>If you only have time for one point about evaluation, make it this one: never report a clinical zone score without the baseline beside it.</a:t>
-            </a:r>
-            <a:endParaRPr lang="en-US" dirty="0"/>
+              <a:t>45s, quick and visual. Red bar = the constant predictor. LONGEST on the left (best clinical score), SHORTEST on the right (least-bad R-squared). One metric says it wins, the other says nothing works. If you only report the left chart, you would ship this.</a:t>
+            </a:r>
           </a:p>
         </p:txBody>
       </p:sp>
@@ -780,10 +774,8 @@
           <a:lstStyle/>
           <a:p>
             <a:r>
-              <a:rPr lang="en-US" dirty="0"/>
-              <a:t/>
-            </a:r>
-            <a:endParaRPr lang="en-US" dirty="0"/>
+              <a:t>90s. Start with the two clues: weighted average = plain average byte-identical (impossible if weights differ), and every density at exactly the 0.01 floor. Then the theorem: equal densities make the measure symmetric, so the integral becomes a fixed function of RANK. Weak models -&gt; lambda &gt; 0 -&gt; beta &gt; 1 -&gt; weight grows toward the SMALLEST. At g=0.01 that is 89.5% on the minimum. Confirmation: corr 0.998 with min(). DO NOT SKIP the dark box - it is not only a bug, it fires exactly when the models cannot generalise.</a:t>
+            </a:r>
           </a:p>
         </p:txBody>
       </p:sp>
@@ -868,10 +860,8 @@
           <a:lstStyle/>
           <a:p>
             <a:r>
-              <a:rPr lang="en-US" dirty="0"/>
-              <a:t/>
-            </a:r>
-            <a:endParaRPr lang="en-US" dirty="0"/>
+              <a:t>60s. CUT IF SHORT - the result is already on slide 12. Three substitutions: apply Sugeno j times, subtract consecutive terms, check the geometric series sums to 1. The red box is the point: weak models force beta &gt; 1, which piles weight on the smallest prediction.</a:t>
+            </a:r>
           </a:p>
         </p:txBody>
       </p:sp>
@@ -956,10 +946,8 @@
           <a:lstStyle/>
           <a:p>
             <a:r>
-              <a:rPr lang="en-US" dirty="0"/>
-              <a:t/>
-            </a:r>
-            <a:endParaRPr lang="en-US" dirty="0"/>
+              <a:t>60s. RANSAC = random sample consensus, unseeded, so identical input gives different output - 5 distinct values in 30 calls. Up to 72% of correlation-dimension values changed. POINT AT THE SECOND NUMBER: 177 other features bit-identical - that is the control proving it was the slope fit, not anything else we changed. Found only because we tested determinism, which almost nobody does.</a:t>
+            </a:r>
           </a:p>
         </p:txBody>
       </p:sp>
@@ -1044,10 +1032,8 @@
           <a:lstStyle/>
           <a:p>
             <a:r>
-              <a:rPr lang="en-US" dirty="0"/>
-              <a:t/>
-            </a:r>
-            <a:endParaRPr lang="en-US" dirty="0"/>
+              <a:t>90s. Four contributions, then the amber box. Say the limits CONFIDENTLY, not apologetically: cannot claim the method never works, only that it does not here under honest evaluation and that its fusion was inactive. Stating limitations is the point of a reproduction, not a weakness.</a:t>
+            </a:r>
           </a:p>
         </p:txBody>
       </p:sp>
@@ -1132,10 +1118,8 @@
           <a:lstStyle/>
           <a:p>
             <a:r>
-              <a:rPr lang="en-US" dirty="0"/>
-              <a:t/>
-            </a:r>
-            <a:endParaRPr lang="en-US" dirty="0"/>
+              <a:t>15s. 'Full write-up with every derivation is in the repository.' Then STOP TALKING. Leave this up, or go back to slide 15 for questions.</a:t>
+            </a:r>
           </a:p>
         </p:txBody>
       </p:sp>
@@ -1220,10 +1204,8 @@
           <a:lstStyle/>
           <a:p>
             <a:r>
-              <a:rPr lang="en-US" dirty="0"/>
-              <a:t>Open here. The audience needs to know what glucose is, why it matters, and that there IS a real reason to look at the heart - before any maths.</a:t>
-            </a:r>
-            <a:endParaRPr lang="en-US" dirty="0"/>
+              <a:t>90s. Three beats: (1) what glucose is and why both directions are dangerous, (2) today it means breaking skin, 590M adults, (3) the amber box - the biology supports DETECTING an event, not reading the exact number. Classification vs regression. This project attempted the number.</a:t>
+            </a:r>
           </a:p>
         </p:txBody>
       </p:sp>
@@ -1308,10 +1290,8 @@
           <a:lstStyle/>
           <a:p>
             <a:r>
-              <a:rPr lang="en-US" dirty="0"/>
-              <a:t/>
-            </a:r>
-            <a:endParaRPr lang="en-US" dirty="0"/>
+              <a:t>90s. IEEE TNNLS, a serious journal. 1.49 mmol/L approaches approved CGM accuracy. They published code but NOT data - so nobody had independently checked it. That is what a reproduction is for. Walk the three stage boxes left to right.</a:t>
+            </a:r>
           </a:p>
         </p:txBody>
       </p:sp>
@@ -1396,10 +1376,8 @@
           <a:lstStyle/>
           <a:p>
             <a:r>
-              <a:rPr lang="en-US" dirty="0"/>
-              <a:t>193 features = 80 ECG wavelet + 80 PPG wavelet + 33 morphological (QT, QTc, ST level, T-wave shape, HRV, PPG pulse shape).</a:t>
-            </a:r>
-            <a:endParaRPr lang="en-US" dirty="0"/>
+              <a:t>90s. SLOW DOWN on the dark box. 2.519 is the standard deviation of glucose, and therefore the error of a model that always guesses the average. It is the score for learning NOTHING. Most papers never report it; we report it beside every result. Everything after this slide depends on them having this.</a:t>
+            </a:r>
           </a:p>
         </p:txBody>
       </p:sp>
@@ -1484,10 +1462,8 @@
           <a:lstStyle/>
           <a:p>
             <a:r>
-              <a:rPr lang="en-US" dirty="0"/>
-              <a:t>Do not rush this slide. The key intuition: a weighted average cannot express that two models overlap. The Choquet integral can, because it scores every subset.</a:t>
-            </a:r>
-            <a:endParaRPr lang="en-US" dirty="0"/>
+              <a:t>2 min, densest slide. START WITH THE ANALOGY at bottom left - three doctors, two trained together so averaging double-counts, one is more experienced. A weighted average handles the second but NOT the first. THEN the formulas. Note the weights (.300,.342,.358) are not the densities (.30,.25,.20) - that gap is the integral doing something a weighted average cannot.</a:t>
+            </a:r>
           </a:p>
         </p:txBody>
       </p:sp>
@@ -1572,10 +1548,8 @@
           <a:lstStyle/>
           <a:p>
             <a:r>
-              <a:rPr lang="en-US" dirty="0"/>
-              <a:t>If asked why a wavelet: measuring 'irregularity' means something different for the fast QRS than for the slow T wave. Separating them lets each be described on its own terms.</a:t>
-            </a:r>
-            <a:endParaRPr lang="en-US" dirty="0"/>
+              <a:t>60s. CUT THIS FIRST if short on time. Key line: a heartbeat mixes fast (QRS, 0.1s) and slow (T wave, 0.3s) things, so measuring the whole window blends them; the wavelet separates them into 8 layers. Then 8 x 10 = 80 per signal. Mention QTc median 0.405s vs textbook 0.35-0.44 as validation.</a:t>
+            </a:r>
           </a:p>
         </p:txBody>
       </p:sp>
@@ -1660,10 +1634,8 @@
           <a:lstStyle/>
           <a:p>
             <a:r>
-              <a:rPr lang="en-US" dirty="0"/>
-              <a:t/>
-            </a:r>
-            <a:endParaRPr lang="en-US" dirty="0"/>
+              <a:t>90s. THE most important concept in the talk. Walk the three boxes. Then the key insight, said slowly: consecutive windows from one person are very similar, so a random split lets the model recognise the PERSON and recall their typical glucose. That is not learning about glucose - but it scores beautifully. Close with the 2026 study: 0.60 under random, -0.08 under participant-aware.</a:t>
+            </a:r>
           </a:p>
         </p:txBody>
       </p:sp>
@@ -1748,10 +1720,8 @@
           <a:lstStyle/>
           <a:p>
             <a:r>
-              <a:rPr lang="en-US" dirty="0"/>
-              <a:t/>
-            </a:r>
-            <a:endParaRPr lang="en-US" dirty="0"/>
+              <a:t>90s. DEFINE R-SQUARED FIRST - 1 perfect, 0 = same as guessing the average, NEGATIVE = worse than guessing. Then: +0.149 random, -0.223 subject-aware, -0.097 leave-one-out. Same data, same code, only the split changed. RAISE THE ORDERING YOURSELF: LOSO is better than subject-aware because it trains on 9 of 10 rather than 4 of 5. Saying it first is far stronger than being caught.</a:t>
+            </a:r>
           </a:p>
         </p:txBody>
       </p:sp>
@@ -1836,10 +1806,8 @@
           <a:lstStyle/>
           <a:p>
             <a:r>
-              <a:rPr lang="en-US" dirty="0"/>
-              <a:t>This is the single most convincing slide. Point at the horizontal band. A model that had learned anything would slope upward along the diagonal.</a:t>
-            </a:r>
-            <a:endParaRPr lang="en-US" dirty="0"/>
+              <a:t>90s. YOUR BEST SLIDE. Trace the diagonal with your hand - that is what a working model looks like. Then trace the horizontal band - whether the truth was 4 or 20, it predicts 6-9. That is what 'no better than the average' looks like drawn. THEN the sting: that same flat band scores 89.4% Zone A+B. PAUSE. Let it land.</a:t>
+            </a:r>
           </a:p>
         </p:txBody>
       </p:sp>

</xml_diff>